<commit_message>
Readme file updated with admin screenshots and also with enhanced demo personas
</commit_message>
<xml_diff>
--- a/GigShield Final Pitch Deck PPT.pptx
+++ b/GigShield Final Pitch Deck PPT.pptx
@@ -2622,6 +2622,124 @@
           </a:p>
         </p:txBody>
       </p:sp>
+      <p:sp>
+        <p:nvSpPr>
+          <p:cNvPr id="11" name="TextBox 10">
+            <a:extLst>
+              <a:ext uri="{FF2B5EF4-FFF2-40B4-BE49-F238E27FC236}">
+                <a16:creationId xmlns:a16="http://schemas.microsoft.com/office/drawing/2014/main" id="{296D00AC-7DA4-9E7C-194C-957113037B97}"/>
+              </a:ext>
+            </a:extLst>
+          </p:cNvPr>
+          <p:cNvSpPr txBox="1"/>
+          <p:nvPr/>
+        </p:nvSpPr>
+        <p:spPr>
+          <a:xfrm>
+            <a:off x="466928" y="3456562"/>
+            <a:ext cx="4105072" cy="1200329"/>
+          </a:xfrm>
+          <a:prstGeom prst="rect">
+            <a:avLst/>
+          </a:prstGeom>
+          <a:noFill/>
+        </p:spPr>
+        <p:txBody>
+          <a:bodyPr wrap="square" rtlCol="0">
+            <a:spAutoFit/>
+          </a:bodyPr>
+          <a:lstStyle/>
+          <a:p>
+            <a:r>
+              <a:rPr lang="en-IN" sz="1200" b="1" dirty="0">
+                <a:solidFill>
+                  <a:schemeClr val="bg1"/>
+                </a:solidFill>
+              </a:rPr>
+              <a:t>Team Name: </a:t>
+            </a:r>
+            <a:r>
+              <a:rPr lang="en-IN" sz="1200" dirty="0">
+                <a:solidFill>
+                  <a:schemeClr val="bg1"/>
+                </a:solidFill>
+              </a:rPr>
+              <a:t>Astha Bhatia</a:t>
+            </a:r>
+            <a:br>
+              <a:rPr lang="en-IN" sz="1200" dirty="0">
+                <a:solidFill>
+                  <a:schemeClr val="bg1"/>
+                </a:solidFill>
+              </a:rPr>
+            </a:br>
+            <a:r>
+              <a:rPr lang="en-IN" sz="1200" b="1" dirty="0">
+                <a:solidFill>
+                  <a:schemeClr val="bg1"/>
+                </a:solidFill>
+              </a:rPr>
+              <a:t>Team Members</a:t>
+            </a:r>
+          </a:p>
+          <a:p>
+            <a:r>
+              <a:rPr lang="en-IN" sz="1200" dirty="0">
+                <a:solidFill>
+                  <a:schemeClr val="bg1"/>
+                </a:solidFill>
+              </a:rPr>
+              <a:t>	Astha Bhatia – </a:t>
+            </a:r>
+            <a:r>
+              <a:rPr lang="en-IN" sz="1200" b="1" dirty="0">
+                <a:solidFill>
+                  <a:schemeClr val="bg1"/>
+                </a:solidFill>
+              </a:rPr>
+              <a:t>Team Leader</a:t>
+            </a:r>
+          </a:p>
+          <a:p>
+            <a:r>
+              <a:rPr lang="en-IN" sz="1200" dirty="0">
+                <a:solidFill>
+                  <a:schemeClr val="bg1"/>
+                </a:solidFill>
+              </a:rPr>
+              <a:t>	Jahanvi</a:t>
+            </a:r>
+          </a:p>
+          <a:p>
+            <a:r>
+              <a:rPr lang="en-IN" sz="1200" dirty="0">
+                <a:solidFill>
+                  <a:schemeClr val="bg1"/>
+                </a:solidFill>
+              </a:rPr>
+              <a:t>	Surbhi Kaushal</a:t>
+            </a:r>
+          </a:p>
+          <a:p>
+            <a:r>
+              <a:rPr lang="en-IN" sz="1200">
+                <a:solidFill>
+                  <a:schemeClr val="bg1"/>
+                </a:solidFill>
+              </a:rPr>
+              <a:t>	Sanjay Kumar  </a:t>
+            </a:r>
+            <a:r>
+              <a:rPr lang="en-IN" sz="1200" dirty="0">
+                <a:solidFill>
+                  <a:schemeClr val="bg1"/>
+                </a:solidFill>
+              </a:rPr>
+              <a:t>S</a:t>
+            </a:r>
+          </a:p>
+        </p:txBody>
+      </p:sp>
     </p:spTree>
   </p:cSld>
   <p:clrMapOvr>

</xml_diff>